<commit_message>
LAste chnages + GitHUb demo
</commit_message>
<xml_diff>
--- a/WorkStuff/Courses/Git/Git_General_Training_Lab/Git_General_Training_ap.ppt.pptx
+++ b/WorkStuff/Courses/Git/Git_General_Training_Lab/Git_General_Training_ap.ppt.pptx
@@ -1682,7 +1682,7 @@
         <p:spPr>
           <a:xfrm>
             <a:off x="1158875" y="692150"/>
-            <a:ext cx="4616450" cy="3462337"/>
+            <a:ext cx="4616450" cy="3462338"/>
           </a:xfrm>
           <a:custGeom>
             <a:avLst/>
@@ -5293,7 +5293,7 @@
         <p:spPr>
           <a:xfrm>
             <a:off x="1158875" y="692150"/>
-            <a:ext cx="4616450" cy="3462337"/>
+            <a:ext cx="4616450" cy="3462338"/>
           </a:xfrm>
           <a:custGeom>
             <a:avLst/>
@@ -12748,46 +12748,6 @@
               <a:t>Ilya Rokhkin</a:t>
             </a:r>
           </a:p>
-          <a:p>
-            <a:pPr marL="0" marR="0" lvl="0" indent="0" algn="l" rtl="0">
-              <a:lnSpc>
-                <a:spcPct val="100000"/>
-              </a:lnSpc>
-              <a:spcBef>
-                <a:spcPts val="0"/>
-              </a:spcBef>
-              <a:spcAft>
-                <a:spcPts val="0"/>
-              </a:spcAft>
-              <a:buClr>
-                <a:srgbClr val="EA411A"/>
-              </a:buClr>
-              <a:buSzPct val="25000"/>
-              <a:buFont typeface="Merriweather"/>
-              <a:buNone/>
-            </a:pPr>
-            <a:r>
-              <a:rPr lang="en-US" sz="2000" b="0" i="0" u="none" strike="noStrike" cap="none" dirty="0">
-                <a:solidFill>
-                  <a:srgbClr val="000000"/>
-                </a:solidFill>
-                <a:latin typeface="Merriweather"/>
-                <a:ea typeface="Merriweather"/>
-                <a:cs typeface="Merriweather"/>
-                <a:sym typeface="Merriweather"/>
-              </a:rPr>
-              <a:t>2023</a:t>
-            </a:r>
-            <a:endParaRPr lang="en-US" sz="2000" b="0" dirty="0">
-              <a:solidFill>
-                <a:srgbClr val="000000"/>
-              </a:solidFill>
-              <a:latin typeface="Merriweather"/>
-              <a:ea typeface="Merriweather"/>
-              <a:cs typeface="Merriweather"/>
-              <a:sym typeface="Merriweather"/>
-            </a:endParaRPr>
-          </a:p>
         </p:txBody>
       </p:sp>
     </p:spTree>
@@ -12981,7 +12941,7 @@
               <a:buChar char="•"/>
             </a:pPr>
             <a:r>
-              <a:rPr lang="en-US" sz="2000" b="0" i="0" u="none">
+              <a:rPr lang="en-US" sz="2000" b="0" i="0" u="none" dirty="0">
                 <a:solidFill>
                   <a:srgbClr val="5E5E5E"/>
                 </a:solidFill>
@@ -12990,10 +12950,10 @@
                 <a:cs typeface="Arial"/>
                 <a:sym typeface="Arial"/>
               </a:rPr>
-              <a:t>Working tree has all files and folders as found in your HEAD,</a:t>
+              <a:t>The working tree has all files and folders as found in your HEAD,</a:t>
             </a:r>
             <a:br>
-              <a:rPr lang="en-US" sz="2000" b="0" i="0" u="none">
+              <a:rPr lang="en-US" sz="2000" b="0" i="0" u="none" dirty="0">
                 <a:solidFill>
                   <a:srgbClr val="5E5E5E"/>
                 </a:solidFill>
@@ -13004,7 +12964,7 @@
               </a:rPr>
             </a:br>
             <a:r>
-              <a:rPr lang="en-US" sz="2000" b="0" i="0" u="none">
+              <a:rPr lang="en-US" sz="2000" b="0" i="0" u="none" dirty="0">
                 <a:solidFill>
                   <a:srgbClr val="5E5E5E"/>
                 </a:solidFill>
@@ -13016,7 +12976,7 @@
               <a:t>plus the changes you made since your last commit</a:t>
             </a:r>
             <a:br>
-              <a:rPr lang="en-US" sz="2000" b="0" i="0" u="none">
+              <a:rPr lang="en-US" sz="2000" b="0" i="0" u="none" dirty="0">
                 <a:solidFill>
                   <a:srgbClr val="5E5E5E"/>
                 </a:solidFill>
@@ -13026,7 +12986,7 @@
                 <a:sym typeface="Arial"/>
               </a:rPr>
             </a:br>
-            <a:endParaRPr lang="en-US" sz="2000" b="0" i="0" u="none">
+            <a:endParaRPr lang="en-US" sz="2000" b="0" i="0" u="none" dirty="0">
               <a:solidFill>
                 <a:srgbClr val="5E5E5E"/>
               </a:solidFill>
@@ -13055,7 +13015,7 @@
               <a:buChar char="•"/>
             </a:pPr>
             <a:r>
-              <a:rPr lang="en-US" sz="2000" b="0" i="0" u="none">
+              <a:rPr lang="en-US" sz="2000" b="0" i="0" u="none" dirty="0">
                 <a:solidFill>
                   <a:srgbClr val="5E5E5E"/>
                 </a:solidFill>
@@ -13067,7 +13027,7 @@
               <a:t> There is only ONE main working tree per repository (and only 1 .git</a:t>
             </a:r>
             <a:br>
-              <a:rPr lang="en-US" sz="2000" b="0" i="0" u="none">
+              <a:rPr lang="en-US" sz="2000" b="0" i="0" u="none" dirty="0">
                 <a:solidFill>
                   <a:srgbClr val="5E5E5E"/>
                 </a:solidFill>
@@ -13078,7 +13038,7 @@
               </a:rPr>
             </a:br>
             <a:r>
-              <a:rPr lang="en-US" sz="2000" b="0" i="0" u="none">
+              <a:rPr lang="en-US" sz="2000" b="0" i="0" u="none" dirty="0">
                 <a:solidFill>
                   <a:srgbClr val="5E5E5E"/>
                 </a:solidFill>
@@ -13104,7 +13064,7 @@
               <a:buNone/>
             </a:pPr>
             <a:br>
-              <a:rPr lang="en-US" sz="2000" b="0" i="0" u="none">
+              <a:rPr lang="en-US" sz="2000" b="0" i="0" u="none" dirty="0">
                 <a:solidFill>
                   <a:srgbClr val="5E5E5E"/>
                 </a:solidFill>
@@ -13114,7 +13074,7 @@
                 <a:sym typeface="Arial"/>
               </a:rPr>
             </a:br>
-            <a:endParaRPr lang="en-US" sz="2000" b="0" i="0" u="none">
+            <a:endParaRPr lang="en-US" sz="2000" b="0" i="0" u="none" dirty="0">
               <a:solidFill>
                 <a:srgbClr val="5E5E5E"/>
               </a:solidFill>
@@ -13137,7 +13097,7 @@
               </a:spcAft>
               <a:buNone/>
             </a:pPr>
-            <a:endParaRPr/>
+            <a:endParaRPr dirty="0"/>
           </a:p>
           <a:p>
             <a:pPr marL="0" marR="0" lvl="0" indent="0" algn="l" rtl="0">
@@ -13152,7 +13112,7 @@
               </a:spcAft>
               <a:buNone/>
             </a:pPr>
-            <a:endParaRPr/>
+            <a:endParaRPr dirty="0"/>
           </a:p>
           <a:p>
             <a:pPr marL="0" marR="0" lvl="0" indent="0" algn="l" rtl="0">
@@ -13167,7 +13127,7 @@
               </a:spcAft>
               <a:buNone/>
             </a:pPr>
-            <a:endParaRPr/>
+            <a:endParaRPr dirty="0"/>
           </a:p>
           <a:p>
             <a:pPr marL="0" marR="0" lvl="0" indent="0" algn="l" rtl="0">
@@ -13182,7 +13142,7 @@
               </a:spcAft>
               <a:buNone/>
             </a:pPr>
-            <a:endParaRPr/>
+            <a:endParaRPr dirty="0"/>
           </a:p>
           <a:p>
             <a:pPr marL="0" marR="0" lvl="0" indent="0" algn="l" rtl="0">
@@ -13198,11 +13158,11 @@
               <a:buNone/>
             </a:pPr>
             <a:r>
-              <a:rPr lang="en-US"/>
+              <a:rPr lang="en-US" dirty="0"/>
               <a:t>The Working Tree</a:t>
             </a:r>
             <a:br>
-              <a:rPr lang="en-US" sz="2000" b="0" i="0" u="none">
+              <a:rPr lang="en-US" sz="2000" b="0" i="0" u="none" dirty="0">
                 <a:solidFill>
                   <a:srgbClr val="5E5E5E"/>
                 </a:solidFill>
@@ -13212,7 +13172,7 @@
                 <a:sym typeface="Arial"/>
               </a:rPr>
             </a:br>
-            <a:endParaRPr lang="en-US" sz="2000" b="0" i="0" u="none">
+            <a:endParaRPr lang="en-US" sz="2000" b="0" i="0" u="none" dirty="0">
               <a:solidFill>
                 <a:srgbClr val="5E5E5E"/>
               </a:solidFill>
@@ -13636,7 +13596,7 @@
               <a:buChar char="•"/>
             </a:pPr>
             <a:r>
-              <a:rPr lang="en-US" sz="2000" b="1" i="0" u="none">
+              <a:rPr lang="en-US" sz="2000" b="1" i="0" u="none" dirty="0">
                 <a:solidFill>
                   <a:srgbClr val="ACACAC"/>
                 </a:solidFill>
@@ -13648,7 +13608,7 @@
               <a:t>Untracked</a:t>
             </a:r>
             <a:r>
-              <a:rPr lang="en-US" sz="2000" b="0" i="0" u="none">
+              <a:rPr lang="en-US" sz="2000" b="0" i="0" u="none" dirty="0">
                 <a:solidFill>
                   <a:srgbClr val="5E5E5E"/>
                 </a:solidFill>
@@ -13673,7 +13633,7 @@
               </a:spcAft>
               <a:buNone/>
             </a:pPr>
-            <a:endParaRPr/>
+            <a:endParaRPr dirty="0"/>
           </a:p>
           <a:p>
             <a:pPr marL="228600" marR="0" lvl="0" indent="-228600" algn="l" rtl="0">
@@ -13694,7 +13654,7 @@
               <a:buChar char="•"/>
             </a:pPr>
             <a:r>
-              <a:rPr lang="en-US" sz="2000" b="1" i="0" u="none">
+              <a:rPr lang="en-US" sz="2000" b="1" i="0" u="none" dirty="0">
                 <a:solidFill>
                   <a:srgbClr val="FF0000"/>
                 </a:solidFill>
@@ -13706,7 +13666,7 @@
               <a:t>Modified</a:t>
             </a:r>
             <a:r>
-              <a:rPr lang="en-US" sz="2000" b="0" i="0" u="none">
+              <a:rPr lang="en-US" sz="2000" b="0" i="0" u="none" dirty="0">
                 <a:solidFill>
                   <a:srgbClr val="5E5E5E"/>
                 </a:solidFill>
@@ -13731,7 +13691,7 @@
               </a:spcAft>
               <a:buNone/>
             </a:pPr>
-            <a:endParaRPr/>
+            <a:endParaRPr dirty="0"/>
           </a:p>
           <a:p>
             <a:pPr marL="228600" marR="0" lvl="0" indent="-228600" algn="l" rtl="0">
@@ -13752,7 +13712,7 @@
               <a:buChar char="•"/>
             </a:pPr>
             <a:r>
-              <a:rPr lang="en-US" sz="2000" b="1" i="0" u="none">
+              <a:rPr lang="en-US" sz="2000" b="1" i="0" u="none" dirty="0">
                 <a:solidFill>
                   <a:srgbClr val="13911F"/>
                 </a:solidFill>
@@ -13764,7 +13724,7 @@
               <a:t>Staged</a:t>
             </a:r>
             <a:r>
-              <a:rPr lang="en-US" sz="2000" b="0" i="0" u="none">
+              <a:rPr lang="en-US" sz="2000" b="0" i="0" u="none" dirty="0">
                 <a:solidFill>
                   <a:srgbClr val="13911F"/>
                 </a:solidFill>
@@ -13776,7 +13736,7 @@
               <a:t> </a:t>
             </a:r>
             <a:r>
-              <a:rPr lang="en-US" sz="2000" b="0" i="0" u="none">
+              <a:rPr lang="en-US" sz="2000" b="0" i="0" u="none" dirty="0">
                 <a:solidFill>
                   <a:srgbClr val="5E5E5E"/>
                 </a:solidFill>
@@ -13801,7 +13761,7 @@
               </a:spcAft>
               <a:buNone/>
             </a:pPr>
-            <a:endParaRPr/>
+            <a:endParaRPr dirty="0"/>
           </a:p>
           <a:p>
             <a:pPr marL="228600" marR="0" lvl="0" indent="-228600" algn="l" rtl="0">
@@ -13822,7 +13782,7 @@
               <a:buChar char="•"/>
             </a:pPr>
             <a:r>
-              <a:rPr lang="en-US" sz="2000" b="1" i="0" u="none">
+              <a:rPr lang="en-US" sz="2000" b="1" i="0" u="none" dirty="0">
                 <a:solidFill>
                   <a:srgbClr val="002060"/>
                 </a:solidFill>
@@ -13834,7 +13794,7 @@
               <a:t>Committed</a:t>
             </a:r>
             <a:r>
-              <a:rPr lang="en-US" sz="2000" b="0" i="0" u="none">
+              <a:rPr lang="en-US" sz="2000" b="0" i="0" u="none" dirty="0">
                 <a:solidFill>
                   <a:srgbClr val="5E5E5E"/>
                 </a:solidFill>
@@ -14534,7 +14494,7 @@
               <a:buNone/>
             </a:pPr>
             <a:r>
-              <a:rPr lang="en-US" sz="2000" b="0" i="0" u="none">
+              <a:rPr lang="en-US" sz="2000" b="0" i="0" u="none" dirty="0">
                 <a:solidFill>
                   <a:srgbClr val="5E5E5E"/>
                 </a:solidFill>
@@ -14543,14 +14503,14 @@
                 <a:cs typeface="Arial"/>
                 <a:sym typeface="Arial"/>
               </a:rPr>
-              <a:t>Almost all of GIT is built around manipulating this simple structure of four different object types. It is sort of </a:t>
-            </a:r>
-            <a:r>
-              <a:rPr lang="en-US"/>
+              <a:t>Almost all the GIT is built around manipulating this simple structure of four different object types. It is sort of </a:t>
+            </a:r>
+            <a:r>
+              <a:rPr lang="en-US" dirty="0"/>
               <a:t>it's</a:t>
             </a:r>
             <a:r>
-              <a:rPr lang="en-US" sz="2000" b="0" i="0" u="none">
+              <a:rPr lang="en-US" sz="2000" b="0" i="0" u="none" dirty="0">
                 <a:solidFill>
                   <a:srgbClr val="5E5E5E"/>
                 </a:solidFill>
@@ -14581,11 +14541,11 @@
               <a:buNone/>
             </a:pPr>
             <a:r>
-              <a:rPr lang="en-US"/>
+              <a:rPr lang="en-US" dirty="0"/>
               <a:t>Let's</a:t>
             </a:r>
             <a:r>
-              <a:rPr lang="en-US" sz="2000" b="0" i="0" u="none">
+              <a:rPr lang="en-US" sz="2000" b="0" i="0" u="none" dirty="0">
                 <a:solidFill>
                   <a:srgbClr val="5E5E5E"/>
                 </a:solidFill>
@@ -14615,7 +14575,7 @@
               <a:buFont typeface="Arial"/>
               <a:buNone/>
             </a:pPr>
-            <a:endParaRPr sz="2000" b="0" i="0" u="none">
+            <a:endParaRPr sz="2000" b="0" i="0" u="none" dirty="0">
               <a:solidFill>
                 <a:srgbClr val="5E5E5E"/>
               </a:solidFill>
@@ -14643,7 +14603,7 @@
               <a:buFont typeface="Arial"/>
               <a:buNone/>
             </a:pPr>
-            <a:endParaRPr sz="2000" b="0" i="0" u="none">
+            <a:endParaRPr sz="2000" b="0" i="0" u="none" dirty="0">
               <a:solidFill>
                 <a:srgbClr val="5E5E5E"/>
               </a:solidFill>
@@ -14671,7 +14631,7 @@
               <a:buFont typeface="Arial"/>
               <a:buNone/>
             </a:pPr>
-            <a:endParaRPr sz="2000" b="0" i="0" u="none">
+            <a:endParaRPr sz="2000" b="0" i="0" u="none" dirty="0">
               <a:solidFill>
                 <a:srgbClr val="5E5E5E"/>
               </a:solidFill>
@@ -14699,7 +14659,7 @@
               <a:buFont typeface="Arial"/>
               <a:buNone/>
             </a:pPr>
-            <a:endParaRPr sz="2000" b="0" i="0" u="none">
+            <a:endParaRPr sz="2000" b="0" i="0" u="none" dirty="0">
               <a:solidFill>
                 <a:srgbClr val="5E5E5E"/>
               </a:solidFill>
@@ -14727,7 +14687,7 @@
               <a:buFont typeface="Arial"/>
               <a:buNone/>
             </a:pPr>
-            <a:endParaRPr sz="2000" b="0" i="0" u="none">
+            <a:endParaRPr sz="2000" b="0" i="0" u="none" dirty="0">
               <a:solidFill>
                 <a:srgbClr val="5E5E5E"/>
               </a:solidFill>
@@ -14755,7 +14715,7 @@
               <a:buFont typeface="Arial"/>
               <a:buNone/>
             </a:pPr>
-            <a:endParaRPr sz="2000" b="0" i="0" u="none">
+            <a:endParaRPr sz="2000" b="0" i="0" u="none" dirty="0">
               <a:solidFill>
                 <a:srgbClr val="5E5E5E"/>
               </a:solidFill>
@@ -14783,7 +14743,7 @@
               <a:buFont typeface="Arial"/>
               <a:buNone/>
             </a:pPr>
-            <a:endParaRPr sz="2000" b="0" i="0" u="none">
+            <a:endParaRPr sz="2000" b="0" i="0" u="none" dirty="0">
               <a:solidFill>
                 <a:srgbClr val="5E5E5E"/>
               </a:solidFill>
@@ -14812,7 +14772,7 @@
               <a:buNone/>
             </a:pPr>
             <a:r>
-              <a:rPr lang="en-US" sz="2000" b="0" i="0" u="none">
+              <a:rPr lang="en-US" sz="2000" b="0" i="0" u="none" dirty="0">
                 <a:solidFill>
                   <a:srgbClr val="5E5E5E"/>
                 </a:solidFill>
@@ -14842,7 +14802,7 @@
               <a:buFont typeface="Arial"/>
               <a:buNone/>
             </a:pPr>
-            <a:endParaRPr sz="2000" b="0" i="0" u="none">
+            <a:endParaRPr sz="2000" b="0" i="0" u="none" dirty="0">
               <a:solidFill>
                 <a:srgbClr val="5E5E5E"/>
               </a:solidFill>
@@ -14870,7 +14830,7 @@
               <a:buFont typeface="Arial"/>
               <a:buNone/>
             </a:pPr>
-            <a:endParaRPr sz="2000" b="0" i="0" u="none">
+            <a:endParaRPr sz="2000" b="0" i="0" u="none" dirty="0">
               <a:solidFill>
                 <a:srgbClr val="5E5E5E"/>
               </a:solidFill>
@@ -14895,7 +14855,7 @@
               <a:buFont typeface="Arial"/>
               <a:buNone/>
             </a:pPr>
-            <a:endParaRPr sz="2000" b="0" i="0" u="none">
+            <a:endParaRPr sz="2000" b="0" i="0" u="none" dirty="0">
               <a:solidFill>
                 <a:srgbClr val="5E5E5E"/>
               </a:solidFill>
@@ -15231,7 +15191,7 @@
               <a:buNone/>
             </a:pPr>
             <a:r>
-              <a:rPr lang="en-US"/>
+              <a:rPr lang="en-US" dirty="0"/>
               <a:t>Commit object with its parent</a:t>
             </a:r>
           </a:p>
@@ -15247,7 +15207,7 @@
               <a:buChar char="●"/>
             </a:pPr>
             <a:r>
-              <a:rPr lang="en-US" sz="2400"/>
+              <a:rPr lang="en-US" sz="2400" dirty="0"/>
               <a:t>Links from tree object to common blobs</a:t>
             </a:r>
           </a:p>
@@ -15357,7 +15317,7 @@
               <a:buNone/>
             </a:pPr>
             <a:r>
-              <a:rPr lang="en-US" sz="1800"/>
+              <a:rPr lang="en-US" sz="1800" dirty="0"/>
               <a:t>Commit Obj</a:t>
             </a:r>
           </a:p>
@@ -15572,7 +15532,7 @@
               <a:buChar char="•"/>
             </a:pPr>
             <a:r>
-              <a:rPr lang="en-US" sz="2000" b="0" i="0" u="none">
+              <a:rPr lang="en-US" sz="2000" b="0" i="0" u="none" dirty="0">
                 <a:solidFill>
                   <a:srgbClr val="5E5E5E"/>
                 </a:solidFill>
@@ -15603,7 +15563,7 @@
               <a:buNone/>
             </a:pPr>
             <a:r>
-              <a:rPr lang="en-US" sz="2000" b="0" i="0" u="none">
+              <a:rPr lang="en-US" sz="2000" b="0" i="0" u="none" dirty="0">
                 <a:solidFill>
                   <a:srgbClr val="5E5E5E"/>
                 </a:solidFill>
@@ -15634,7 +15594,7 @@
               <a:buNone/>
             </a:pPr>
             <a:r>
-              <a:rPr lang="en-US" sz="2000" b="0" i="0" u="none">
+              <a:rPr lang="en-US" sz="2000" b="0" i="0" u="none" dirty="0">
                 <a:solidFill>
                   <a:srgbClr val="5E5E5E"/>
                 </a:solidFill>
@@ -15662,17 +15622,17 @@
               <a:buNone/>
             </a:pPr>
             <a:br>
-              <a:rPr lang="en-US"/>
+              <a:rPr lang="en-US" dirty="0"/>
             </a:br>
             <a:r>
-              <a:rPr lang="en-US"/>
+              <a:rPr lang="en-US" dirty="0"/>
               <a:t>Each commit has </a:t>
             </a:r>
             <a:br>
-              <a:rPr lang="en-US"/>
+              <a:rPr lang="en-US" dirty="0"/>
             </a:br>
             <a:r>
-              <a:rPr lang="en-US"/>
+              <a:rPr lang="en-US" dirty="0"/>
               <a:t>Author and Committer</a:t>
             </a:r>
           </a:p>
@@ -15692,25 +15652,25 @@
               <a:buNone/>
             </a:pPr>
             <a:r>
-              <a:rPr lang="en-US" b="1"/>
-              <a:t>Author</a:t>
-            </a:r>
-            <a:r>
-              <a:rPr lang="en-US"/>
+              <a:rPr lang="en-US" b="1" dirty="0"/>
+              <a:t>The Author</a:t>
+            </a:r>
+            <a:r>
+              <a:rPr lang="en-US" dirty="0"/>
               <a:t> is who really </a:t>
             </a:r>
             <a:br>
-              <a:rPr lang="en-US"/>
+              <a:rPr lang="en-US" dirty="0"/>
             </a:br>
             <a:r>
-              <a:rPr lang="en-US"/>
-              <a:t>wrote the code and </a:t>
+              <a:rPr lang="en-US" dirty="0"/>
+              <a:t>wrote the code, and </a:t>
             </a:r>
             <a:br>
-              <a:rPr lang="en-US"/>
+              <a:rPr lang="en-US" dirty="0"/>
             </a:br>
             <a:r>
-              <a:rPr lang="en-US"/>
+              <a:rPr lang="en-US" dirty="0"/>
               <a:t>committed</a:t>
             </a:r>
           </a:p>
@@ -15730,32 +15690,32 @@
               <a:buNone/>
             </a:pPr>
             <a:r>
-              <a:rPr lang="en-US" b="1"/>
+              <a:rPr lang="en-US" b="1" dirty="0"/>
               <a:t>Committer</a:t>
             </a:r>
             <a:r>
-              <a:rPr lang="en-US"/>
+              <a:rPr lang="en-US" dirty="0"/>
               <a:t>, if not the </a:t>
             </a:r>
             <a:br>
-              <a:rPr lang="en-US"/>
+              <a:rPr lang="en-US" dirty="0"/>
             </a:br>
             <a:r>
-              <a:rPr lang="en-US"/>
-              <a:t>same as Author, took </a:t>
+              <a:rPr lang="en-US" dirty="0"/>
+              <a:t>same as the Author, took </a:t>
             </a:r>
             <a:br>
-              <a:rPr lang="en-US"/>
+              <a:rPr lang="en-US" dirty="0"/>
             </a:br>
             <a:r>
-              <a:rPr lang="en-US"/>
+              <a:rPr lang="en-US" dirty="0"/>
               <a:t>Original commit and</a:t>
             </a:r>
             <a:br>
-              <a:rPr lang="en-US"/>
+              <a:rPr lang="en-US" dirty="0"/>
             </a:br>
             <a:r>
-              <a:rPr lang="en-US"/>
+              <a:rPr lang="en-US" dirty="0"/>
               <a:t>reused it in his branch </a:t>
             </a:r>
           </a:p>
@@ -16602,7 +16562,7 @@
               <a:buNone/>
             </a:pPr>
             <a:r>
-              <a:rPr lang="en-US" sz="3600"/>
+              <a:rPr lang="en-US" sz="3600" dirty="0"/>
               <a:t>Demo</a:t>
             </a:r>
           </a:p>
@@ -16614,13 +16574,13 @@
               <a:buNone/>
             </a:pPr>
             <a:r>
-              <a:rPr lang="en-US" sz="3600"/>
+              <a:rPr lang="en-US" sz="3600" dirty="0"/>
               <a:t>Lab 3</a:t>
             </a:r>
             <a:br>
-              <a:rPr lang="en-US" sz="3600"/>
+              <a:rPr lang="en-US" sz="3600" dirty="0"/>
             </a:br>
-            <a:endParaRPr lang="en-US" sz="3600"/>
+            <a:endParaRPr lang="en-US" sz="3600" dirty="0"/>
           </a:p>
           <a:p>
             <a:pPr marL="0" lvl="0" indent="0" rtl="0">
@@ -16630,7 +16590,7 @@
               <a:buNone/>
             </a:pPr>
             <a:r>
-              <a:rPr lang="en-US" sz="3000"/>
+              <a:rPr lang="en-US" sz="3000" dirty="0"/>
               <a:t>Teamwork, parallel work: </a:t>
             </a:r>
           </a:p>
@@ -16642,8 +16602,8 @@
               <a:buSzPct val="100000"/>
             </a:pPr>
             <a:r>
-              <a:rPr lang="en-US" sz="3000"/>
-              <a:t>We will clone second work repo2</a:t>
+              <a:rPr lang="en-US" sz="3000" dirty="0"/>
+              <a:t>We will clone the second work repository2</a:t>
             </a:r>
           </a:p>
           <a:p>
@@ -16654,8 +16614,8 @@
               <a:buSzPct val="100000"/>
             </a:pPr>
             <a:r>
-              <a:rPr lang="en-US" sz="3000"/>
-              <a:t>Will commit changes in both repositories</a:t>
+              <a:rPr lang="en-US" sz="3000" dirty="0"/>
+              <a:t>We will commit changes in both repositories</a:t>
             </a:r>
           </a:p>
           <a:p>
@@ -16666,7 +16626,7 @@
               <a:buSzPct val="100000"/>
             </a:pPr>
             <a:r>
-              <a:rPr lang="en-US" sz="3000"/>
+              <a:rPr lang="en-US" sz="3000" dirty="0"/>
               <a:t>Push and pull with silent rebase to apply the commit of one repo into another</a:t>
             </a:r>
           </a:p>
@@ -16678,7 +16638,7 @@
               <a:buSzPct val="100000"/>
             </a:pPr>
             <a:r>
-              <a:rPr lang="en-US" sz="3000"/>
+              <a:rPr lang="en-US" sz="3000" dirty="0"/>
               <a:t>Overview results </a:t>
             </a:r>
           </a:p>
@@ -28897,7 +28857,7 @@
               <a:buFont typeface="Arial"/>
               <a:buNone/>
             </a:pPr>
-            <a:endParaRPr sz="1800" b="1" i="0" u="none">
+            <a:endParaRPr sz="1800" b="1" i="0" u="none" dirty="0">
               <a:solidFill>
                 <a:srgbClr val="5E5E5E"/>
               </a:solidFill>
@@ -28925,7 +28885,7 @@
               <a:buFont typeface="Arial"/>
               <a:buNone/>
             </a:pPr>
-            <a:endParaRPr sz="1800" b="1" i="0" u="none">
+            <a:endParaRPr sz="1800" b="1" i="0" u="none" dirty="0">
               <a:solidFill>
                 <a:srgbClr val="5E5E5E"/>
               </a:solidFill>
@@ -28954,7 +28914,7 @@
               <a:buChar char="•"/>
             </a:pPr>
             <a:r>
-              <a:rPr lang="en-US" sz="2000" b="1" i="0" u="none">
+              <a:rPr lang="en-US" sz="2000" b="1" i="0" u="none" dirty="0">
                 <a:solidFill>
                   <a:srgbClr val="5E5E5E"/>
                 </a:solidFill>
@@ -28985,7 +28945,7 @@
               <a:buNone/>
             </a:pPr>
             <a:r>
-              <a:rPr lang="en-US" sz="1800" b="0" i="0" u="none">
+              <a:rPr lang="en-US" sz="1800" b="0" i="0" u="none" dirty="0">
                 <a:solidFill>
                   <a:srgbClr val="000000"/>
                 </a:solidFill>
@@ -29015,7 +28975,7 @@
               <a:buFont typeface="Arial"/>
               <a:buNone/>
             </a:pPr>
-            <a:endParaRPr sz="1800" b="1" i="0" u="none">
+            <a:endParaRPr sz="1800" b="1" i="0" u="none" dirty="0">
               <a:solidFill>
                 <a:srgbClr val="0070C0"/>
               </a:solidFill>
@@ -29043,7 +29003,7 @@
               <a:buFont typeface="Arial"/>
               <a:buNone/>
             </a:pPr>
-            <a:endParaRPr sz="1800" b="1" i="0" u="none">
+            <a:endParaRPr sz="1800" b="1" i="0" u="none" dirty="0">
               <a:solidFill>
                 <a:srgbClr val="0070C0"/>
               </a:solidFill>
@@ -29068,7 +29028,7 @@
               <a:buFont typeface="Arial"/>
               <a:buNone/>
             </a:pPr>
-            <a:endParaRPr sz="1800" b="1" i="0" u="none">
+            <a:endParaRPr sz="1800" b="1" i="0" u="none" dirty="0">
               <a:solidFill>
                 <a:srgbClr val="0070C0"/>
               </a:solidFill>
@@ -29321,7 +29281,7 @@
               <a:buNone/>
             </a:pPr>
             <a:r>
-              <a:rPr lang="en-US" sz="3600"/>
+              <a:rPr lang="en-US" sz="3600" dirty="0"/>
               <a:t>Demo</a:t>
             </a:r>
           </a:p>
@@ -29333,13 +29293,13 @@
               <a:buNone/>
             </a:pPr>
             <a:r>
-              <a:rPr lang="en-US" sz="3600"/>
+              <a:rPr lang="en-US" sz="3600" dirty="0"/>
               <a:t>Lab 4</a:t>
             </a:r>
             <a:br>
-              <a:rPr lang="en-US" sz="3600"/>
+              <a:rPr lang="en-US" sz="3600" dirty="0"/>
             </a:br>
-            <a:endParaRPr lang="en-US" sz="3600"/>
+            <a:endParaRPr lang="en-US" sz="3600" dirty="0"/>
           </a:p>
           <a:p>
             <a:pPr marL="457200" lvl="0" indent="-419100" rtl="0">
@@ -29349,8 +29309,8 @@
               <a:buSzPct val="100000"/>
             </a:pPr>
             <a:r>
-              <a:rPr lang="en-US" sz="3000"/>
-              <a:t>Teamwork, parallel work with rebase and conflicts resolution: </a:t>
+              <a:rPr lang="en-US" sz="3000" dirty="0"/>
+              <a:t>Teamwork, parallel work with rebase, and conflict resolution: </a:t>
             </a:r>
           </a:p>
           <a:p>
@@ -29361,8 +29321,8 @@
               <a:buSzPct val="100000"/>
             </a:pPr>
             <a:r>
-              <a:rPr lang="en-US" sz="3000"/>
-              <a:t>We will do commits in both repos, with change in the same line of the same file</a:t>
+              <a:rPr lang="en-US" sz="3000" dirty="0"/>
+              <a:t>We will do commits in both repositories, with changes in the same line of the same file</a:t>
             </a:r>
           </a:p>
           <a:p>
@@ -29373,8 +29333,8 @@
               <a:buSzPct val="100000"/>
             </a:pPr>
             <a:r>
-              <a:rPr lang="en-US" sz="3000"/>
-              <a:t>Pull with rebase, resolve conflicts, save the resolution file</a:t>
+              <a:rPr lang="en-US" sz="3000" dirty="0"/>
+              <a:t>Pull with rebase, resolve conflicts, and save the resolution file</a:t>
             </a:r>
           </a:p>
           <a:p>
@@ -29385,8 +29345,8 @@
               <a:buSzPct val="100000"/>
             </a:pPr>
             <a:r>
-              <a:rPr lang="en-US" sz="3000"/>
-              <a:t>Add the file to the staging area - means resolve.</a:t>
+              <a:rPr lang="en-US" sz="3000" dirty="0"/>
+              <a:t>Adding the file to the staging area means resolving the issue.</a:t>
             </a:r>
           </a:p>
           <a:p>
@@ -29397,7 +29357,7 @@
               <a:buSzPct val="100000"/>
             </a:pPr>
             <a:r>
-              <a:rPr lang="en-US" sz="3000"/>
+              <a:rPr lang="en-US" sz="3000" dirty="0"/>
               <a:t>Commit and push</a:t>
             </a:r>
           </a:p>
@@ -32201,7 +32161,7 @@
               <a:buNone/>
             </a:pPr>
             <a:r>
-              <a:rPr lang="en-US" sz="3600"/>
+              <a:rPr lang="en-US" sz="3600" dirty="0"/>
               <a:t>Demo</a:t>
             </a:r>
           </a:p>
@@ -32213,13 +32173,13 @@
               <a:buNone/>
             </a:pPr>
             <a:r>
-              <a:rPr lang="en-US" sz="3600"/>
+              <a:rPr lang="en-US" sz="3600" dirty="0"/>
               <a:t>Lab 5 - 7</a:t>
             </a:r>
             <a:br>
-              <a:rPr lang="en-US" sz="3600"/>
+              <a:rPr lang="en-US" sz="3600" dirty="0"/>
             </a:br>
-            <a:endParaRPr lang="en-US" sz="3600"/>
+            <a:endParaRPr lang="en-US" sz="3600" dirty="0"/>
           </a:p>
           <a:p>
             <a:pPr marL="457200" lvl="0" indent="-419100" rtl="0">
@@ -32229,8 +32189,8 @@
               <a:buSzPct val="100000"/>
             </a:pPr>
             <a:r>
-              <a:rPr lang="en-US" sz="3000"/>
-              <a:t>We will create tag</a:t>
+              <a:rPr lang="en-US" sz="3000" dirty="0"/>
+              <a:t>We will create a tag</a:t>
             </a:r>
           </a:p>
           <a:p>
@@ -32241,7 +32201,7 @@
               <a:buSzPct val="100000"/>
             </a:pPr>
             <a:r>
-              <a:rPr lang="en-US" sz="3000"/>
+              <a:rPr lang="en-US" sz="3000" dirty="0"/>
               <a:t>Create branch bugfix from the tag</a:t>
             </a:r>
           </a:p>
@@ -32253,8 +32213,8 @@
               <a:buNone/>
             </a:pPr>
             <a:r>
-              <a:rPr lang="en-US" sz="3000"/>
-              <a:t>Will do bugfix commit in bugfix branch</a:t>
+              <a:rPr lang="en-US" sz="3000" dirty="0"/>
+              <a:t>I will do a bugfix commit in the bugfix branch</a:t>
             </a:r>
           </a:p>
           <a:p>
@@ -32265,8 +32225,8 @@
               <a:buNone/>
             </a:pPr>
             <a:r>
-              <a:rPr lang="en-US" sz="3000"/>
-              <a:t>Check out master branch and commit new change</a:t>
+              <a:rPr lang="en-US" sz="3000" dirty="0"/>
+              <a:t>Check out the master branch and commit a new change</a:t>
             </a:r>
           </a:p>
           <a:p>
@@ -32277,7 +32237,7 @@
               <a:buSzPct val="100000"/>
             </a:pPr>
             <a:r>
-              <a:rPr lang="en-US" sz="3000"/>
+              <a:rPr lang="en-US" sz="3000" dirty="0"/>
               <a:t>Merge bugfix branch</a:t>
             </a:r>
           </a:p>
@@ -32289,7 +32249,7 @@
               <a:buNone/>
             </a:pPr>
             <a:r>
-              <a:rPr lang="en-US" sz="3000"/>
+              <a:rPr lang="en-US" sz="3000" dirty="0"/>
               <a:t>Overview results</a:t>
             </a:r>
           </a:p>
@@ -33420,7 +33380,7 @@
               <a:buNone/>
             </a:pPr>
             <a:r>
-              <a:rPr lang="en-US" sz="2000" b="0" i="0" u="none" strike="noStrike" cap="none">
+              <a:rPr lang="en-US" sz="2000" b="0" i="0" u="none" strike="noStrike" cap="none" dirty="0">
                 <a:solidFill>
                   <a:srgbClr val="5E5E5E"/>
                 </a:solidFill>
@@ -33445,7 +33405,7 @@
               <a:buChar char="–"/>
             </a:pPr>
             <a:r>
-              <a:rPr lang="en-US"/>
+              <a:rPr lang="en-US" dirty="0"/>
               <a:t>Git Architecture, data model</a:t>
             </a:r>
           </a:p>
@@ -33462,7 +33422,7 @@
               <a:buChar char="–"/>
             </a:pPr>
             <a:r>
-              <a:rPr lang="en-US"/>
+              <a:rPr lang="en-US" dirty="0"/>
               <a:t>DVCS, Repository, Commit, Parent Commit, Tree, Blob, Index.</a:t>
             </a:r>
           </a:p>
@@ -33479,8 +33439,8 @@
               <a:buChar char="–"/>
             </a:pPr>
             <a:r>
-              <a:rPr lang="en-US"/>
-              <a:t>Staged, Modified, Committed files.</a:t>
+              <a:rPr lang="en-US" dirty="0"/>
+              <a:t>Staged, Modified, and Committed files.</a:t>
             </a:r>
           </a:p>
           <a:p>
@@ -33496,8 +33456,8 @@
               <a:buChar char="–"/>
             </a:pPr>
             <a:r>
-              <a:rPr lang="en-US"/>
-              <a:t>Basic commands to work in Repository and outside.</a:t>
+              <a:rPr lang="en-US" dirty="0"/>
+              <a:t>Basic commands to work in the Repository and outside.</a:t>
             </a:r>
           </a:p>
           <a:p>
@@ -33513,7 +33473,7 @@
               <a:buChar char="–"/>
             </a:pPr>
             <a:r>
-              <a:rPr lang="en-US"/>
+              <a:rPr lang="en-US" dirty="0"/>
               <a:t>Sharing work with peers.</a:t>
             </a:r>
           </a:p>
@@ -33530,7 +33490,7 @@
               <a:buChar char="–"/>
             </a:pPr>
             <a:r>
-              <a:rPr lang="en-US"/>
+              <a:rPr lang="en-US" dirty="0"/>
               <a:t>Best practices</a:t>
             </a:r>
           </a:p>
@@ -33552,7 +33512,7 @@
               <a:buFont typeface="Arial"/>
               <a:buNone/>
             </a:pPr>
-            <a:endParaRPr sz="2000" b="0" i="0" u="none" strike="noStrike" cap="none">
+            <a:endParaRPr sz="2000" b="0" i="0" u="none" strike="noStrike" cap="none" dirty="0">
               <a:solidFill>
                 <a:srgbClr val="5E5E5E"/>
               </a:solidFill>
@@ -33581,7 +33541,7 @@
               <a:buNone/>
             </a:pPr>
             <a:r>
-              <a:rPr lang="en-US" sz="2000" b="0" i="0" u="none" strike="noStrike" cap="none">
+              <a:rPr lang="en-US" sz="2000" b="0" i="0" u="none" strike="noStrike" cap="none" dirty="0">
                 <a:solidFill>
                   <a:srgbClr val="5E5E5E"/>
                 </a:solidFill>
@@ -34410,7 +34370,7 @@
               <a:buNone/>
             </a:pPr>
             <a:r>
-              <a:rPr lang="en-US" sz="3600"/>
+              <a:rPr lang="en-US" sz="3600" dirty="0"/>
               <a:t>Lab 8 - 10</a:t>
             </a:r>
           </a:p>
@@ -34421,7 +34381,7 @@
               </a:spcBef>
               <a:buNone/>
             </a:pPr>
-            <a:endParaRPr sz="3000"/>
+            <a:endParaRPr sz="3000" dirty="0"/>
           </a:p>
           <a:p>
             <a:pPr marL="457200" lvl="0" indent="-419100" algn="l" rtl="0">
@@ -34431,7 +34391,7 @@
               <a:buSzPct val="100000"/>
             </a:pPr>
             <a:r>
-              <a:rPr lang="en-US" sz="3000"/>
+              <a:rPr lang="en-US" sz="3000" dirty="0"/>
               <a:t>We will create branch bugfix2, from Release_01</a:t>
             </a:r>
           </a:p>
@@ -34443,8 +34403,8 @@
               <a:buNone/>
             </a:pPr>
             <a:r>
-              <a:rPr lang="en-US" sz="3000"/>
-              <a:t>Cherry-pick 1 commit from master branch</a:t>
+              <a:rPr lang="en-US" sz="3000" dirty="0"/>
+              <a:t>Cherry-pick 1 commit from the master branch</a:t>
             </a:r>
           </a:p>
           <a:p>
@@ -34455,7 +34415,7 @@
               <a:buSzPct val="100000"/>
             </a:pPr>
             <a:r>
-              <a:rPr lang="en-US" sz="3000"/>
+              <a:rPr lang="en-US" sz="3000" dirty="0"/>
               <a:t>Undo modified file, undo staged file</a:t>
             </a:r>
           </a:p>
@@ -34467,8 +34427,8 @@
               <a:buNone/>
             </a:pPr>
             <a:r>
-              <a:rPr lang="en-US" sz="3000"/>
-              <a:t>Undo latest local commit, revert pushed commit</a:t>
+              <a:rPr lang="en-US" sz="3000" dirty="0"/>
+              <a:t>Undo the latest local commit, revert the pushed commit</a:t>
             </a:r>
           </a:p>
           <a:p>
@@ -34479,8 +34439,8 @@
               <a:buSzPct val="100000"/>
             </a:pPr>
             <a:r>
-              <a:rPr lang="en-US" sz="3000"/>
-              <a:t>Stash meanwhile work aside, make commit, return work from stash</a:t>
+              <a:rPr lang="en-US" sz="3000" dirty="0"/>
+              <a:t>Stash meanwhile work aside, make a commit, return work from stash</a:t>
             </a:r>
           </a:p>
         </p:txBody>
@@ -34586,13 +34546,13 @@
               <a:buNone/>
             </a:pPr>
             <a:r>
-              <a:rPr lang="en-US" sz="3600"/>
+              <a:rPr lang="en-US" sz="3600" dirty="0"/>
               <a:t>Lab 11 - 13</a:t>
             </a:r>
             <a:br>
-              <a:rPr lang="en-US" sz="3600"/>
+              <a:rPr lang="en-US" sz="3600" dirty="0"/>
             </a:br>
-            <a:endParaRPr lang="en-US" sz="3600"/>
+            <a:endParaRPr lang="en-US" sz="3600" dirty="0"/>
           </a:p>
           <a:p>
             <a:pPr marL="457200" lvl="0" indent="-419100" rtl="0">
@@ -34602,7 +34562,7 @@
               <a:buSzPct val="100000"/>
             </a:pPr>
             <a:r>
-              <a:rPr lang="en-US" sz="3000"/>
+              <a:rPr lang="en-US" sz="3000" dirty="0"/>
               <a:t>Format patch in 1 repository, and apply it in another repository	</a:t>
             </a:r>
           </a:p>
@@ -34614,8 +34574,8 @@
               <a:buSzPct val="100000"/>
             </a:pPr>
             <a:r>
-              <a:rPr lang="en-US" sz="3000"/>
-              <a:t>We will create 2 local commits and squash them to 1 commit by interactive rebase, and push only 1 commit to remote repository  </a:t>
+              <a:rPr lang="en-US" sz="3000" dirty="0"/>
+              <a:t>We will create 2 local commits squash them to 1 commit by interactive rebase, and push only 1 commit to the remote repository  </a:t>
             </a:r>
           </a:p>
           <a:p>
@@ -34626,8 +34586,8 @@
               <a:buSzPct val="100000"/>
             </a:pPr>
             <a:r>
-              <a:rPr lang="en-US" sz="3000"/>
-              <a:t>Create commit in 1 repository and pull it from another repository, without pushing to origin repository</a:t>
+              <a:rPr lang="en-US" sz="3000" dirty="0"/>
+              <a:t>Create a commit in 1 repository and pull it from another repository, without pushing it to the origin repository</a:t>
             </a:r>
           </a:p>
         </p:txBody>
@@ -35453,7 +35413,7 @@
               <a:buChar char="•"/>
             </a:pPr>
             <a:r>
-              <a:rPr lang="en-US" sz="2000" b="0" i="0" u="none">
+              <a:rPr lang="en-US" sz="2000" b="0" i="0" u="none" dirty="0">
                 <a:solidFill>
                   <a:srgbClr val="5E5E5E"/>
                 </a:solidFill>
@@ -35484,7 +35444,7 @@
               <a:buChar char="•"/>
             </a:pPr>
             <a:r>
-              <a:rPr lang="en-US" sz="2000" b="0" i="0" u="none">
+              <a:rPr lang="en-US" sz="2000" b="0" i="0" u="none" dirty="0">
                 <a:solidFill>
                   <a:srgbClr val="5E5E5E"/>
                 </a:solidFill>
@@ -35515,7 +35475,7 @@
               <a:buChar char="•"/>
             </a:pPr>
             <a:r>
-              <a:rPr lang="en-US" sz="2000" b="0" i="0" u="none">
+              <a:rPr lang="en-US" sz="2000" b="0" i="0" u="none" dirty="0">
                 <a:solidFill>
                   <a:srgbClr val="5E5E5E"/>
                 </a:solidFill>
@@ -35527,7 +35487,7 @@
               <a:t>Atomic transactions, commit, </a:t>
             </a:r>
             <a:r>
-              <a:rPr lang="en-US"/>
+              <a:rPr lang="en-US" dirty="0"/>
               <a:t>cross repository</a:t>
             </a:r>
           </a:p>
@@ -35550,7 +35510,7 @@
               <a:buChar char="•"/>
             </a:pPr>
             <a:r>
-              <a:rPr lang="en-US"/>
+              <a:rPr lang="en-US" dirty="0"/>
               <a:t>Commits (Change) management</a:t>
             </a:r>
           </a:p>
@@ -35573,7 +35533,7 @@
               <a:buChar char="•"/>
             </a:pPr>
             <a:r>
-              <a:rPr lang="en-US" sz="2000" b="0" i="0" u="none">
+              <a:rPr lang="en-US" sz="2000" b="0" i="0" u="none" dirty="0">
                 <a:solidFill>
                   <a:srgbClr val="5E5E5E"/>
                 </a:solidFill>
@@ -35585,11 +35545,11 @@
               <a:t>A clea</a:t>
             </a:r>
             <a:r>
-              <a:rPr lang="en-US"/>
+              <a:rPr lang="en-US" dirty="0"/>
               <a:t>r</a:t>
             </a:r>
             <a:r>
-              <a:rPr lang="en-US" sz="2000" b="0" i="0" u="none">
+              <a:rPr lang="en-US" sz="2000" b="0" i="0" u="none" dirty="0">
                 <a:solidFill>
                   <a:srgbClr val="5E5E5E"/>
                 </a:solidFill>
@@ -35620,7 +35580,7 @@
               <a:buChar char="•"/>
             </a:pPr>
             <a:r>
-              <a:rPr lang="en-US" sz="2000" b="0" i="0" u="none">
+              <a:rPr lang="en-US" sz="2000" b="0" i="0" u="none" dirty="0">
                 <a:solidFill>
                   <a:srgbClr val="5E5E5E"/>
                 </a:solidFill>
@@ -35632,7 +35592,7 @@
               <a:t>Suited to</a:t>
             </a:r>
             <a:r>
-              <a:rPr lang="en-US"/>
+              <a:rPr lang="en-US" dirty="0"/>
               <a:t> handle everything from small to very large projects with speed and efficiency</a:t>
             </a:r>
           </a:p>
@@ -35655,7 +35615,7 @@
               <a:buChar char="•"/>
             </a:pPr>
             <a:r>
-              <a:rPr lang="en-US" sz="2000" b="0" i="0" u="none">
+              <a:rPr lang="en-US" sz="2000" b="0" i="0" u="none" dirty="0">
                 <a:solidFill>
                   <a:srgbClr val="5E5E5E"/>
                 </a:solidFill>
@@ -35682,7 +35642,7 @@
               <a:buFont typeface="Arial"/>
               <a:buNone/>
             </a:pPr>
-            <a:endParaRPr sz="2000" b="0" i="0" u="none">
+            <a:endParaRPr sz="2000" b="0" i="0" u="none" dirty="0">
               <a:solidFill>
                 <a:srgbClr val="5E5E5E"/>
               </a:solidFill>
@@ -36463,7 +36423,7 @@
               <a:buChar char="•"/>
             </a:pPr>
             <a:r>
-              <a:rPr lang="en-US" sz="2000" b="0" i="0" u="none">
+              <a:rPr lang="en-US" sz="2000" b="0" i="0" u="none" dirty="0">
                 <a:solidFill>
                   <a:srgbClr val="5E5E5E"/>
                 </a:solidFill>
@@ -36475,7 +36435,7 @@
               <a:t>The combination of these branches defines a relationship</a:t>
             </a:r>
             <a:br>
-              <a:rPr lang="en-US" sz="2000" b="0" i="0" u="none">
+              <a:rPr lang="en-US" sz="2000" b="0" i="0" u="none" dirty="0">
                 <a:solidFill>
                   <a:srgbClr val="5E5E5E"/>
                 </a:solidFill>
@@ -36486,7 +36446,7 @@
               </a:rPr>
             </a:br>
             <a:r>
-              <a:rPr lang="en-US" sz="2000" b="0" i="0" u="none">
+              <a:rPr lang="en-US" sz="2000" b="0" i="0" u="none" dirty="0">
                 <a:solidFill>
                   <a:srgbClr val="5E5E5E"/>
                 </a:solidFill>
@@ -36517,7 +36477,7 @@
               <a:buChar char="•"/>
             </a:pPr>
             <a:r>
-              <a:rPr lang="en-US" sz="2000" b="0" i="0" u="none">
+              <a:rPr lang="en-US" sz="2000" b="0" i="0" u="none" dirty="0">
                 <a:solidFill>
                   <a:srgbClr val="5E5E5E"/>
                 </a:solidFill>
@@ -36529,7 +36489,7 @@
               <a:t>When a repository is cloned, Git automatically creates </a:t>
             </a:r>
             <a:r>
-              <a:rPr lang="en-US" sz="2000" b="1" i="0" u="none">
+              <a:rPr lang="en-US" sz="2000" b="1" i="0" u="none" dirty="0">
                 <a:solidFill>
                   <a:srgbClr val="5E5E5E"/>
                 </a:solidFill>
@@ -36541,7 +36501,7 @@
               <a:t>remote-tracking branches </a:t>
             </a:r>
             <a:r>
-              <a:rPr lang="en-US" sz="2000" b="0" i="0" u="none">
+              <a:rPr lang="en-US" sz="2000" b="0" i="0" u="none" dirty="0">
                 <a:solidFill>
                   <a:srgbClr val="5E5E5E"/>
                 </a:solidFill>
@@ -36553,7 +36513,7 @@
               <a:t>(e.g., origin/master) for the remote branches and a </a:t>
             </a:r>
             <a:r>
-              <a:rPr lang="en-US" sz="2000" b="1" i="0" u="none">
+              <a:rPr lang="en-US" sz="2000" b="1" i="0" u="none" dirty="0">
                 <a:solidFill>
                   <a:srgbClr val="5E5E5E"/>
                 </a:solidFill>
@@ -36565,7 +36525,7 @@
               <a:t>tracking branch </a:t>
             </a:r>
             <a:r>
-              <a:rPr lang="en-US" sz="2000" b="0" i="0" u="none">
+              <a:rPr lang="en-US" sz="2000" b="0" i="0" u="none" dirty="0">
                 <a:solidFill>
                   <a:srgbClr val="5E5E5E"/>
                 </a:solidFill>
@@ -36577,7 +36537,7 @@
               <a:t>(e.g., master) to allow for local changes in relationship to the remote branch</a:t>
             </a:r>
             <a:br>
-              <a:rPr lang="en-US" sz="2000" b="0" i="0" u="none">
+              <a:rPr lang="en-US" sz="2000" b="0" i="0" u="none" dirty="0">
                 <a:solidFill>
                   <a:srgbClr val="5E5E5E"/>
                 </a:solidFill>
@@ -36588,7 +36548,7 @@
               </a:rPr>
             </a:br>
             <a:br>
-              <a:rPr lang="en-US" sz="2000" b="0" i="0" u="none">
+              <a:rPr lang="en-US" sz="2000" b="0" i="0" u="none" dirty="0">
                 <a:solidFill>
                   <a:srgbClr val="5E5E5E"/>
                 </a:solidFill>
@@ -36598,7 +36558,7 @@
                 <a:sym typeface="Arial"/>
               </a:rPr>
             </a:br>
-            <a:endParaRPr lang="en-US" sz="2000" b="0" i="0" u="none">
+            <a:endParaRPr lang="en-US" sz="2000" b="0" i="0" u="none" dirty="0">
               <a:solidFill>
                 <a:srgbClr val="5E5E5E"/>
               </a:solidFill>
@@ -37039,7 +36999,7 @@
               <a:buNone/>
             </a:pPr>
             <a:r>
-              <a:rPr lang="en-US" sz="3400" b="0" i="0" u="none" strike="noStrike" cap="none">
+              <a:rPr lang="en-US" sz="3400" b="0" i="0" u="none" strike="noStrike" cap="none" dirty="0">
                 <a:solidFill>
                   <a:schemeClr val="dk2"/>
                 </a:solidFill>
@@ -37051,7 +37011,7 @@
               <a:t>GIT </a:t>
             </a:r>
             <a:br>
-              <a:rPr lang="en-US" sz="3400" b="0" i="0" u="none" strike="noStrike" cap="none">
+              <a:rPr lang="en-US" sz="3400" b="0" i="0" u="none" strike="noStrike" cap="none" dirty="0">
                 <a:solidFill>
                   <a:schemeClr val="dk2"/>
                 </a:solidFill>
@@ -37062,7 +37022,7 @@
               </a:rPr>
             </a:br>
             <a:r>
-              <a:rPr lang="en-US"/>
+              <a:rPr lang="en-US" dirty="0"/>
               <a:t>Architecture</a:t>
             </a:r>
           </a:p>
@@ -37084,7 +37044,7 @@
               <a:buFont typeface="Arial"/>
               <a:buNone/>
             </a:pPr>
-            <a:endParaRPr/>
+            <a:endParaRPr dirty="0"/>
           </a:p>
           <a:p>
             <a:pPr marL="0" marR="0" lvl="0" indent="0" algn="l" rtl="0">
@@ -37105,7 +37065,7 @@
               <a:buNone/>
             </a:pPr>
             <a:r>
-              <a:rPr lang="en-US" sz="1800"/>
+              <a:rPr lang="en-US" sz="1800" dirty="0"/>
               <a:t>1 Local repo</a:t>
             </a:r>
           </a:p>
@@ -37128,7 +37088,7 @@
               <a:buNone/>
             </a:pPr>
             <a:r>
-              <a:rPr lang="en-US" sz="1800"/>
+              <a:rPr lang="en-US" sz="1800" dirty="0"/>
               <a:t>2 Remote (Origin)</a:t>
             </a:r>
           </a:p>
@@ -37151,14 +37111,14 @@
               <a:buNone/>
             </a:pPr>
             <a:r>
-              <a:rPr lang="en-US" sz="1800"/>
+              <a:rPr lang="en-US" sz="1800" dirty="0"/>
               <a:t>3 Common</a:t>
             </a:r>
             <a:br>
-              <a:rPr lang="en-US" sz="1800"/>
+              <a:rPr lang="en-US" sz="1800" dirty="0"/>
             </a:br>
             <a:r>
-              <a:rPr lang="en-US" sz="1800"/>
+              <a:rPr lang="en-US" sz="1800" dirty="0"/>
               <a:t>(Community) Remote Origin</a:t>
             </a:r>
           </a:p>
@@ -37372,7 +37332,7 @@
               <a:buNone/>
             </a:pPr>
             <a:r>
-              <a:rPr lang="en-US" sz="3600"/>
+              <a:rPr lang="en-US" sz="3600" dirty="0"/>
               <a:t>Demo</a:t>
             </a:r>
           </a:p>
@@ -37384,13 +37344,13 @@
               <a:buNone/>
             </a:pPr>
             <a:r>
-              <a:rPr lang="en-US" sz="3600"/>
+              <a:rPr lang="en-US" sz="3600" dirty="0"/>
               <a:t>Lab 1 - 2</a:t>
             </a:r>
             <a:br>
-              <a:rPr lang="en-US" sz="3600"/>
+              <a:rPr lang="en-US" sz="3600" dirty="0"/>
             </a:br>
-            <a:endParaRPr lang="en-US" sz="3600"/>
+            <a:endParaRPr lang="en-US" sz="3600" dirty="0"/>
           </a:p>
           <a:p>
             <a:pPr marL="457200" lvl="0" indent="-419100" rtl="0">
@@ -37400,7 +37360,7 @@
               <a:buSzPct val="100000"/>
             </a:pPr>
             <a:r>
-              <a:rPr lang="en-US" sz="3000"/>
+              <a:rPr lang="en-US" sz="3000" dirty="0"/>
               <a:t>We will configure your git user and e-mail</a:t>
             </a:r>
           </a:p>
@@ -37412,8 +37372,8 @@
               <a:buNone/>
             </a:pPr>
             <a:r>
-              <a:rPr lang="en-US" sz="3000"/>
-              <a:t>Will create remote, bare repository in home dir</a:t>
+              <a:rPr lang="en-US" sz="3000" dirty="0"/>
+              <a:t>Will create a remote, bare repository in the home directory</a:t>
             </a:r>
           </a:p>
           <a:p>
@@ -37424,8 +37384,8 @@
               <a:buNone/>
             </a:pPr>
             <a:r>
-              <a:rPr lang="en-US" sz="3000"/>
-              <a:t>Clone it to work repo1 in home dir also, add,commit and push</a:t>
+              <a:rPr lang="en-US" sz="3000" dirty="0"/>
+              <a:t>Clone it to work repository1 in the home directory also, add, commit, and push</a:t>
             </a:r>
           </a:p>
           <a:p>
@@ -37436,13 +37396,13 @@
               <a:buSzPct val="100000"/>
             </a:pPr>
             <a:r>
-              <a:rPr lang="en-US" sz="3000"/>
-              <a:t>Restructure files, add, commit and push</a:t>
+              <a:rPr lang="en-US" sz="3000" dirty="0"/>
+              <a:t>Restructure files, add, commit, and push</a:t>
             </a:r>
             <a:br>
-              <a:rPr lang="en-US" sz="3000"/>
+              <a:rPr lang="en-US" sz="3000" dirty="0"/>
             </a:br>
-            <a:endParaRPr lang="en-US" sz="3000"/>
+            <a:endParaRPr lang="en-US" sz="3000" dirty="0"/>
           </a:p>
         </p:txBody>
       </p:sp>

</xml_diff>